<commit_message>
TriageAI review decks: generic wording for any reviewer, 3D symptom illustrations, country and language page
</commit_message>
<xml_diff>
--- a/triageai-review/TriageAI_Clinical_Review_Deck.pptx
+++ b/triageai-review/TriageAI_Clinical_Review_Deck.pptx
@@ -11,6 +11,7 @@
     <p:sldId id="259" r:id="rId10"/>
     <p:sldId id="260" r:id="rId11"/>
     <p:sldId id="261" r:id="rId12"/>
+    <p:sldId id="262" r:id="rId13"/>
   </p:sldIdLst>
   <p:sldSz cx="12191695" cy="6858000" type="screen4x3"/>
   <p:notesSz cx="6858000" cy="9144000"/>
@@ -3520,7 +3521,7 @@
                 </a:solidFill>
                 <a:latin typeface="Calibri"/>
               </a:rPr>
-              <a:t>2 / 6</a:t>
+              <a:t>2 / 7</a:t>
             </a:r>
           </a:p>
         </p:txBody>
@@ -4204,7 +4205,7 @@
                 </a:solidFill>
                 <a:latin typeface="Calibri"/>
               </a:rPr>
-              <a:t>3 / 6</a:t>
+              <a:t>3 / 7</a:t>
             </a:r>
           </a:p>
         </p:txBody>
@@ -4964,7 +4965,7 @@
                 </a:solidFill>
                 <a:latin typeface="Calibri"/>
               </a:rPr>
-              <a:t>4 / 6</a:t>
+              <a:t>4 / 7</a:t>
             </a:r>
           </a:p>
         </p:txBody>
@@ -5748,7 +5749,7 @@
                 </a:solidFill>
                 <a:latin typeface="Calibri"/>
               </a:rPr>
-              <a:t>Safeguards and what we have not done</a:t>
+              <a:t>Built for one country and one language at a time</a:t>
             </a:r>
           </a:p>
         </p:txBody>
@@ -5787,7 +5788,7 @@
                 </a:solidFill>
                 <a:latin typeface="Calibri"/>
               </a:rPr>
-              <a:t>5 / 6</a:t>
+              <a:t>5 / 7</a:t>
             </a:r>
           </a:p>
         </p:txBody>
@@ -5909,21 +5910,93 @@
                 </a:solidFill>
                 <a:latin typeface="Calibri"/>
               </a:rPr>
-              <a:t>Please be as critical as you like</a:t>
-            </a:r>
-          </a:p>
-        </p:txBody>
-      </p:sp>
-      <p:sp>
-        <p:nvSpPr>
-          <p:cNvPr id="8" name="TextBox 7"/>
+              <a:t>Each version is localised, not a single global app</a:t>
+            </a:r>
+          </a:p>
+        </p:txBody>
+      </p:sp>
+      <p:pic>
+        <p:nvPicPr>
+          <p:cNvPr id="8" name="Picture 7" descr="f_headache.png"/>
+          <p:cNvPicPr>
+            <a:picLocks noChangeAspect="1"/>
+          </p:cNvPicPr>
+          <p:nvPr/>
+        </p:nvPicPr>
+        <p:blipFill>
+          <a:blip r:embed="rId2"/>
+          <a:stretch>
+            <a:fillRect/>
+          </a:stretch>
+        </p:blipFill>
+        <p:spPr>
+          <a:xfrm>
+            <a:off x="548640" y="1828800"/>
+            <a:ext cx="2286000" cy="2286000"/>
+          </a:xfrm>
+          <a:prstGeom prst="rect">
+            <a:avLst/>
+          </a:prstGeom>
+        </p:spPr>
+      </p:pic>
+      <p:pic>
+        <p:nvPicPr>
+          <p:cNvPr id="9" name="Picture 8" descr="m_chest_b.png"/>
+          <p:cNvPicPr>
+            <a:picLocks noChangeAspect="1"/>
+          </p:cNvPicPr>
+          <p:nvPr/>
+        </p:nvPicPr>
+        <p:blipFill>
+          <a:blip r:embed="rId3"/>
+          <a:stretch>
+            <a:fillRect/>
+          </a:stretch>
+        </p:blipFill>
+        <p:spPr>
+          <a:xfrm>
+            <a:off x="3017520" y="1828800"/>
+            <a:ext cx="2286000" cy="2286000"/>
+          </a:xfrm>
+          <a:prstGeom prst="rect">
+            <a:avLst/>
+          </a:prstGeom>
+        </p:spPr>
+      </p:pic>
+      <p:pic>
+        <p:nvPicPr>
+          <p:cNvPr id="10" name="Picture 9" descr="f_stroke.png"/>
+          <p:cNvPicPr>
+            <a:picLocks noChangeAspect="1"/>
+          </p:cNvPicPr>
+          <p:nvPr/>
+        </p:nvPicPr>
+        <p:blipFill>
+          <a:blip r:embed="rId4"/>
+          <a:stretch>
+            <a:fillRect/>
+          </a:stretch>
+        </p:blipFill>
+        <p:spPr>
+          <a:xfrm>
+            <a:off x="5486400" y="1828800"/>
+            <a:ext cx="2286000" cy="2286000"/>
+          </a:xfrm>
+          <a:prstGeom prst="rect">
+            <a:avLst/>
+          </a:prstGeom>
+        </p:spPr>
+      </p:pic>
+      <p:sp>
+        <p:nvSpPr>
+          <p:cNvPr id="11" name="TextBox 10"/>
           <p:cNvSpPr txBox="1"/>
           <p:nvPr/>
         </p:nvSpPr>
         <p:spPr>
           <a:xfrm>
-            <a:off x="548640" y="1828800"/>
-            <a:ext cx="5486400" cy="457200"/>
+            <a:off x="548640" y="4206240"/>
+            <a:ext cx="7315200" cy="640080"/>
           </a:xfrm>
           <a:prstGeom prst="rect">
             <a:avLst/>
@@ -5942,27 +6015,73 @@
               </a:spcAft>
             </a:pPr>
             <a:r>
-              <a:rPr sz="1800" b="1">
-                <a:solidFill>
-                  <a:srgbClr val="0E7C86"/>
-                </a:solidFill>
-                <a:latin typeface="Calibri"/>
-              </a:rPr>
-              <a:t>In place</a:t>
-            </a:r>
-          </a:p>
-        </p:txBody>
-      </p:sp>
-      <p:sp>
-        <p:nvSpPr>
-          <p:cNvPr id="9" name="TextBox 8"/>
+              <a:rPr sz="1400" b="0">
+                <a:solidFill>
+                  <a:srgbClr val="444F5A"/>
+                </a:solidFill>
+                <a:latin typeface="Calibri"/>
+              </a:rPr>
+              <a:t>Illustrations like these appear next to each question, so a person with low literacy can recognise the symptom.</a:t>
+            </a:r>
+          </a:p>
+        </p:txBody>
+      </p:sp>
+      <p:sp>
+        <p:nvSpPr>
+          <p:cNvPr id="12" name="Rectangle 11"/>
+          <p:cNvSpPr/>
+          <p:nvPr/>
+        </p:nvSpPr>
+        <p:spPr>
+          <a:xfrm>
+            <a:off x="8138160" y="1828800"/>
+            <a:ext cx="3566160" cy="3749039"/>
+          </a:xfrm>
+          <a:prstGeom prst="rect">
+            <a:avLst/>
+          </a:prstGeom>
+          <a:solidFill>
+            <a:srgbClr val="F2F6F9"/>
+          </a:solidFill>
+          <a:ln w="15875">
+            <a:solidFill>
+              <a:srgbClr val="0E7C86"/>
+            </a:solidFill>
+          </a:ln>
+          <a:effectLst/>
+        </p:spPr>
+        <p:style>
+          <a:lnRef idx="1">
+            <a:schemeClr val="accent1"/>
+          </a:lnRef>
+          <a:fillRef idx="3">
+            <a:schemeClr val="accent1"/>
+          </a:fillRef>
+          <a:effectRef idx="2">
+            <a:schemeClr val="accent1"/>
+          </a:effectRef>
+          <a:fontRef idx="minor">
+            <a:schemeClr val="lt1"/>
+          </a:fontRef>
+        </p:style>
+        <p:txBody>
+          <a:bodyPr rtlCol="0" anchor="ctr"/>
+          <a:lstStyle/>
+          <a:p>
+            <a:pPr algn="ctr"/>
+          </a:p>
+        </p:txBody>
+      </p:sp>
+      <p:sp>
+        <p:nvSpPr>
+          <p:cNvPr id="13" name="TextBox 12"/>
           <p:cNvSpPr txBox="1"/>
           <p:nvPr/>
         </p:nvSpPr>
         <p:spPr>
           <a:xfrm>
-            <a:off x="548640" y="2331720"/>
-            <a:ext cx="5486400" cy="3657600"/>
+            <a:off x="8275320" y="1874519"/>
+            <a:ext cx="3291840" cy="365760"/>
           </a:xfrm>
           <a:prstGeom prst="rect">
             <a:avLst/>
@@ -5981,75 +6100,27 @@
               </a:spcAft>
             </a:pPr>
             <a:r>
-              <a:rPr sz="1600" b="0">
-                <a:solidFill>
-                  <a:srgbClr val="444F5A"/>
-                </a:solidFill>
-                <a:latin typeface="Calibri"/>
-              </a:rPr>
-              <a:t>A disclaimer on every result</a:t>
-            </a:r>
-          </a:p>
-          <a:p>
-            <a:pPr algn="l">
-              <a:spcAft>
-                <a:spcPts val="600"/>
-              </a:spcAft>
-            </a:pPr>
-            <a:r>
-              <a:rPr sz="1600" b="0">
-                <a:solidFill>
-                  <a:srgbClr val="444F5A"/>
-                </a:solidFill>
-                <a:latin typeface="Calibri"/>
-              </a:rPr>
-              <a:t>The clinician makes the final judgment</a:t>
-            </a:r>
-          </a:p>
-          <a:p>
-            <a:pPr algn="l">
-              <a:spcAft>
-                <a:spcPts val="600"/>
-              </a:spcAft>
-            </a:pPr>
-            <a:r>
-              <a:rPr sz="1600" b="0">
-                <a:solidFill>
-                  <a:srgbClr val="444F5A"/>
-                </a:solidFill>
-                <a:latin typeface="Calibri"/>
-              </a:rPr>
-              <a:t>No account, name or personal health data is requested</a:t>
-            </a:r>
-          </a:p>
-          <a:p>
-            <a:pPr algn="l">
-              <a:spcAft>
-                <a:spcPts val="600"/>
-              </a:spcAft>
-            </a:pPr>
-            <a:r>
-              <a:rPr sz="1600" b="0">
-                <a:solidFill>
-                  <a:srgbClr val="444F5A"/>
-                </a:solidFill>
-                <a:latin typeface="Calibri"/>
-              </a:rPr>
-              <a:t>Counters start from zero and count real use only</a:t>
-            </a:r>
-          </a:p>
-        </p:txBody>
-      </p:sp>
-      <p:sp>
-        <p:nvSpPr>
-          <p:cNvPr id="10" name="TextBox 9"/>
+              <a:rPr sz="1600" b="1">
+                <a:solidFill>
+                  <a:srgbClr val="0E7C86"/>
+                </a:solidFill>
+                <a:latin typeface="Calibri"/>
+              </a:rPr>
+              <a:t>One country, one language</a:t>
+            </a:r>
+          </a:p>
+        </p:txBody>
+      </p:sp>
+      <p:sp>
+        <p:nvSpPr>
+          <p:cNvPr id="14" name="TextBox 13"/>
           <p:cNvSpPr txBox="1"/>
           <p:nvPr/>
         </p:nvSpPr>
         <p:spPr>
           <a:xfrm>
-            <a:off x="6400800" y="1828800"/>
-            <a:ext cx="5303520" cy="457200"/>
+            <a:off x="8275320" y="2331720"/>
+            <a:ext cx="3291840" cy="3200400"/>
           </a:xfrm>
           <a:prstGeom prst="rect">
             <a:avLst/>
@@ -6068,27 +6139,59 @@
               </a:spcAft>
             </a:pPr>
             <a:r>
-              <a:rPr sz="1800" b="1">
-                <a:solidFill>
-                  <a:srgbClr val="B42318"/>
-                </a:solidFill>
-                <a:latin typeface="Calibri"/>
-              </a:rPr>
-              <a:t>Not yet done</a:t>
-            </a:r>
-          </a:p>
-        </p:txBody>
-      </p:sp>
-      <p:sp>
-        <p:nvSpPr>
-          <p:cNvPr id="11" name="TextBox 10"/>
+              <a:rPr sz="1400" b="0">
+                <a:solidFill>
+                  <a:srgbClr val="444F5A"/>
+                </a:solidFill>
+                <a:latin typeface="Calibri"/>
+              </a:rPr>
+              <a:t>Local emergency numbers and clinics</a:t>
+            </a:r>
+          </a:p>
+          <a:p>
+            <a:pPr algn="l">
+              <a:spcAft>
+                <a:spcPts val="600"/>
+              </a:spcAft>
+            </a:pPr>
+            <a:r>
+              <a:rPr sz="1400" b="0">
+                <a:solidFill>
+                  <a:srgbClr val="444F5A"/>
+                </a:solidFill>
+                <a:latin typeface="Calibri"/>
+              </a:rPr>
+              <a:t>Local language and phrasing, such as pidgin where suited</a:t>
+            </a:r>
+          </a:p>
+          <a:p>
+            <a:pPr algn="l">
+              <a:spcAft>
+                <a:spcPts val="600"/>
+              </a:spcAft>
+            </a:pPr>
+            <a:r>
+              <a:rPr sz="1400" b="0">
+                <a:solidFill>
+                  <a:srgbClr val="444F5A"/>
+                </a:solidFill>
+                <a:latin typeface="Calibri"/>
+              </a:rPr>
+              <a:t>Local medical guidance reviewed by clinicians who practise there</a:t>
+            </a:r>
+          </a:p>
+        </p:txBody>
+      </p:sp>
+      <p:sp>
+        <p:nvSpPr>
+          <p:cNvPr id="15" name="TextBox 14"/>
           <p:cNvSpPr txBox="1"/>
           <p:nvPr/>
         </p:nvSpPr>
         <p:spPr>
           <a:xfrm>
-            <a:off x="6400800" y="2331720"/>
-            <a:ext cx="5303520" cy="3840480"/>
+            <a:off x="548640" y="4937760"/>
+            <a:ext cx="7315200" cy="1371600"/>
           </a:xfrm>
           <a:prstGeom prst="rect">
             <a:avLst/>
@@ -6107,77 +6210,13 @@
               </a:spcAft>
             </a:pPr>
             <a:r>
-              <a:rPr sz="1600" b="0">
-                <a:solidFill>
-                  <a:srgbClr val="444F5A"/>
-                </a:solidFill>
-                <a:latin typeface="Calibri"/>
-              </a:rPr>
-              <a:t>No clinical validation or testing with real patients</a:t>
-            </a:r>
-          </a:p>
-          <a:p>
-            <a:pPr algn="l">
-              <a:spcAft>
-                <a:spcPts val="600"/>
-              </a:spcAft>
-            </a:pPr>
-            <a:r>
-              <a:rPr sz="1600" b="0">
-                <a:solidFill>
-                  <a:srgbClr val="444F5A"/>
-                </a:solidFill>
-                <a:latin typeface="Calibri"/>
-              </a:rPr>
-              <a:t>No review of the urgent and moderate lists by a doctor or nurse</a:t>
-            </a:r>
-          </a:p>
-          <a:p>
-            <a:pPr algn="l">
-              <a:spcAft>
-                <a:spcPts val="600"/>
-              </a:spcAft>
-            </a:pPr>
-            <a:r>
-              <a:rPr sz="1600" b="0">
-                <a:solidFill>
-                  <a:srgbClr val="444F5A"/>
-                </a:solidFill>
-                <a:latin typeface="Calibri"/>
-              </a:rPr>
-              <a:t>No handling of children, pregnancy or chronic conditions</a:t>
-            </a:r>
-          </a:p>
-          <a:p>
-            <a:pPr algn="l">
-              <a:spcAft>
-                <a:spcPts val="600"/>
-              </a:spcAft>
-            </a:pPr>
-            <a:r>
-              <a:rPr sz="1600" b="0">
-                <a:solidFill>
-                  <a:srgbClr val="444F5A"/>
-                </a:solidFill>
-                <a:latin typeface="Calibri"/>
-              </a:rPr>
-              <a:t>No local-language or pidgin phrasing</a:t>
-            </a:r>
-          </a:p>
-          <a:p>
-            <a:pPr algn="l">
-              <a:spcAft>
-                <a:spcPts val="600"/>
-              </a:spcAft>
-            </a:pPr>
-            <a:r>
-              <a:rPr sz="1600" b="0">
-                <a:solidFill>
-                  <a:srgbClr val="444F5A"/>
-                </a:solidFill>
-                <a:latin typeface="Calibri"/>
-              </a:rPr>
-              <a:t>No real clinic directory</a:t>
+              <a:rPr sz="1500" b="1">
+                <a:solidFill>
+                  <a:srgbClr val="0B2A4A"/>
+                </a:solidFill>
+                <a:latin typeface="Calibri"/>
+              </a:rPr>
+              <a:t>Your call: what must change for your country or language? Which local terms for these symptoms do patients actually use?</a:t>
             </a:r>
           </a:p>
         </p:txBody>
@@ -6278,7 +6317,7 @@
                 </a:solidFill>
                 <a:latin typeface="Calibri"/>
               </a:rPr>
-              <a:t>What we are asking of you</a:t>
+              <a:t>Safeguards and what we have not done</a:t>
             </a:r>
           </a:p>
         </p:txBody>
@@ -6317,7 +6356,537 @@
                 </a:solidFill>
                 <a:latin typeface="Calibri"/>
               </a:rPr>
-              <a:t>6 / 6</a:t>
+              <a:t>6 / 7</a:t>
+            </a:r>
+          </a:p>
+        </p:txBody>
+      </p:sp>
+      <p:sp>
+        <p:nvSpPr>
+          <p:cNvPr id="5" name="Rectangle 4"/>
+          <p:cNvSpPr/>
+          <p:nvPr/>
+        </p:nvSpPr>
+        <p:spPr>
+          <a:xfrm>
+            <a:off x="0" y="6492240"/>
+            <a:ext cx="12191695" cy="365760"/>
+          </a:xfrm>
+          <a:prstGeom prst="rect">
+            <a:avLst/>
+          </a:prstGeom>
+          <a:solidFill>
+            <a:srgbClr val="F2F6F9"/>
+          </a:solidFill>
+          <a:ln>
+            <a:noFill/>
+          </a:ln>
+          <a:effectLst/>
+        </p:spPr>
+        <p:style>
+          <a:lnRef idx="1">
+            <a:schemeClr val="accent1"/>
+          </a:lnRef>
+          <a:fillRef idx="3">
+            <a:schemeClr val="accent1"/>
+          </a:fillRef>
+          <a:effectRef idx="2">
+            <a:schemeClr val="accent1"/>
+          </a:effectRef>
+          <a:fontRef idx="minor">
+            <a:schemeClr val="lt1"/>
+          </a:fontRef>
+        </p:style>
+        <p:txBody>
+          <a:bodyPr rtlCol="0" anchor="ctr"/>
+          <a:lstStyle/>
+          <a:p>
+            <a:pPr algn="ctr"/>
+          </a:p>
+        </p:txBody>
+      </p:sp>
+      <p:sp>
+        <p:nvSpPr>
+          <p:cNvPr id="6" name="TextBox 5"/>
+          <p:cNvSpPr txBox="1"/>
+          <p:nvPr/>
+        </p:nvSpPr>
+        <p:spPr>
+          <a:xfrm>
+            <a:off x="548640" y="6519672"/>
+            <a:ext cx="11155680" cy="274320"/>
+          </a:xfrm>
+          <a:prstGeom prst="rect">
+            <a:avLst/>
+          </a:prstGeom>
+          <a:noFill/>
+        </p:spPr>
+        <p:txBody>
+          <a:bodyPr wrap="square" anchor="t" lIns="45720" rIns="45720" tIns="27432" bIns="27432">
+            <a:spAutoFit/>
+          </a:bodyPr>
+          <a:lstStyle/>
+          <a:p>
+            <a:pPr algn="l">
+              <a:spcAft>
+                <a:spcPts val="600"/>
+              </a:spcAft>
+            </a:pPr>
+            <a:r>
+              <a:rPr sz="1100" b="0">
+                <a:solidFill>
+                  <a:srgbClr val="444F5A"/>
+                </a:solidFill>
+                <a:latin typeface="Calibri"/>
+              </a:rPr>
+              <a:t>TriageAI  |  Work in progress  |  Prepared for clinical review  |  BETONIQ WEST LTD</a:t>
+            </a:r>
+          </a:p>
+        </p:txBody>
+      </p:sp>
+      <p:sp>
+        <p:nvSpPr>
+          <p:cNvPr id="7" name="TextBox 6"/>
+          <p:cNvSpPr txBox="1"/>
+          <p:nvPr/>
+        </p:nvSpPr>
+        <p:spPr>
+          <a:xfrm>
+            <a:off x="548640" y="1280160"/>
+            <a:ext cx="11064240" cy="548640"/>
+          </a:xfrm>
+          <a:prstGeom prst="rect">
+            <a:avLst/>
+          </a:prstGeom>
+          <a:noFill/>
+        </p:spPr>
+        <p:txBody>
+          <a:bodyPr wrap="square" anchor="t" lIns="45720" rIns="45720" tIns="27432" bIns="27432">
+            <a:spAutoFit/>
+          </a:bodyPr>
+          <a:lstStyle/>
+          <a:p>
+            <a:pPr algn="l">
+              <a:spcAft>
+                <a:spcPts val="600"/>
+              </a:spcAft>
+            </a:pPr>
+            <a:r>
+              <a:rPr sz="1800" b="0">
+                <a:solidFill>
+                  <a:srgbClr val="0E7C86"/>
+                </a:solidFill>
+                <a:latin typeface="Calibri"/>
+              </a:rPr>
+              <a:t>Please be as critical as you like</a:t>
+            </a:r>
+          </a:p>
+        </p:txBody>
+      </p:sp>
+      <p:sp>
+        <p:nvSpPr>
+          <p:cNvPr id="8" name="TextBox 7"/>
+          <p:cNvSpPr txBox="1"/>
+          <p:nvPr/>
+        </p:nvSpPr>
+        <p:spPr>
+          <a:xfrm>
+            <a:off x="548640" y="1828800"/>
+            <a:ext cx="5486400" cy="457200"/>
+          </a:xfrm>
+          <a:prstGeom prst="rect">
+            <a:avLst/>
+          </a:prstGeom>
+          <a:noFill/>
+        </p:spPr>
+        <p:txBody>
+          <a:bodyPr wrap="square" anchor="t" lIns="45720" rIns="45720" tIns="27432" bIns="27432">
+            <a:spAutoFit/>
+          </a:bodyPr>
+          <a:lstStyle/>
+          <a:p>
+            <a:pPr algn="l">
+              <a:spcAft>
+                <a:spcPts val="600"/>
+              </a:spcAft>
+            </a:pPr>
+            <a:r>
+              <a:rPr sz="1800" b="1">
+                <a:solidFill>
+                  <a:srgbClr val="0E7C86"/>
+                </a:solidFill>
+                <a:latin typeface="Calibri"/>
+              </a:rPr>
+              <a:t>In place</a:t>
+            </a:r>
+          </a:p>
+        </p:txBody>
+      </p:sp>
+      <p:sp>
+        <p:nvSpPr>
+          <p:cNvPr id="9" name="TextBox 8"/>
+          <p:cNvSpPr txBox="1"/>
+          <p:nvPr/>
+        </p:nvSpPr>
+        <p:spPr>
+          <a:xfrm>
+            <a:off x="548640" y="2331720"/>
+            <a:ext cx="5486400" cy="3657600"/>
+          </a:xfrm>
+          <a:prstGeom prst="rect">
+            <a:avLst/>
+          </a:prstGeom>
+          <a:noFill/>
+        </p:spPr>
+        <p:txBody>
+          <a:bodyPr wrap="square" anchor="t" lIns="45720" rIns="45720" tIns="27432" bIns="27432">
+            <a:spAutoFit/>
+          </a:bodyPr>
+          <a:lstStyle/>
+          <a:p>
+            <a:pPr algn="l">
+              <a:spcAft>
+                <a:spcPts val="600"/>
+              </a:spcAft>
+            </a:pPr>
+            <a:r>
+              <a:rPr sz="1600" b="0">
+                <a:solidFill>
+                  <a:srgbClr val="444F5A"/>
+                </a:solidFill>
+                <a:latin typeface="Calibri"/>
+              </a:rPr>
+              <a:t>A disclaimer on every result</a:t>
+            </a:r>
+          </a:p>
+          <a:p>
+            <a:pPr algn="l">
+              <a:spcAft>
+                <a:spcPts val="600"/>
+              </a:spcAft>
+            </a:pPr>
+            <a:r>
+              <a:rPr sz="1600" b="0">
+                <a:solidFill>
+                  <a:srgbClr val="444F5A"/>
+                </a:solidFill>
+                <a:latin typeface="Calibri"/>
+              </a:rPr>
+              <a:t>The clinician makes the final judgment</a:t>
+            </a:r>
+          </a:p>
+          <a:p>
+            <a:pPr algn="l">
+              <a:spcAft>
+                <a:spcPts val="600"/>
+              </a:spcAft>
+            </a:pPr>
+            <a:r>
+              <a:rPr sz="1600" b="0">
+                <a:solidFill>
+                  <a:srgbClr val="444F5A"/>
+                </a:solidFill>
+                <a:latin typeface="Calibri"/>
+              </a:rPr>
+              <a:t>No account, name or personal health data is requested</a:t>
+            </a:r>
+          </a:p>
+          <a:p>
+            <a:pPr algn="l">
+              <a:spcAft>
+                <a:spcPts val="600"/>
+              </a:spcAft>
+            </a:pPr>
+            <a:r>
+              <a:rPr sz="1600" b="0">
+                <a:solidFill>
+                  <a:srgbClr val="444F5A"/>
+                </a:solidFill>
+                <a:latin typeface="Calibri"/>
+              </a:rPr>
+              <a:t>Counters start from zero and count real use only</a:t>
+            </a:r>
+          </a:p>
+        </p:txBody>
+      </p:sp>
+      <p:sp>
+        <p:nvSpPr>
+          <p:cNvPr id="10" name="TextBox 9"/>
+          <p:cNvSpPr txBox="1"/>
+          <p:nvPr/>
+        </p:nvSpPr>
+        <p:spPr>
+          <a:xfrm>
+            <a:off x="6400800" y="1828800"/>
+            <a:ext cx="5303520" cy="457200"/>
+          </a:xfrm>
+          <a:prstGeom prst="rect">
+            <a:avLst/>
+          </a:prstGeom>
+          <a:noFill/>
+        </p:spPr>
+        <p:txBody>
+          <a:bodyPr wrap="square" anchor="t" lIns="45720" rIns="45720" tIns="27432" bIns="27432">
+            <a:spAutoFit/>
+          </a:bodyPr>
+          <a:lstStyle/>
+          <a:p>
+            <a:pPr algn="l">
+              <a:spcAft>
+                <a:spcPts val="600"/>
+              </a:spcAft>
+            </a:pPr>
+            <a:r>
+              <a:rPr sz="1800" b="1">
+                <a:solidFill>
+                  <a:srgbClr val="B42318"/>
+                </a:solidFill>
+                <a:latin typeface="Calibri"/>
+              </a:rPr>
+              <a:t>Not yet done</a:t>
+            </a:r>
+          </a:p>
+        </p:txBody>
+      </p:sp>
+      <p:sp>
+        <p:nvSpPr>
+          <p:cNvPr id="11" name="TextBox 10"/>
+          <p:cNvSpPr txBox="1"/>
+          <p:nvPr/>
+        </p:nvSpPr>
+        <p:spPr>
+          <a:xfrm>
+            <a:off x="6400800" y="2331720"/>
+            <a:ext cx="5303520" cy="3840480"/>
+          </a:xfrm>
+          <a:prstGeom prst="rect">
+            <a:avLst/>
+          </a:prstGeom>
+          <a:noFill/>
+        </p:spPr>
+        <p:txBody>
+          <a:bodyPr wrap="square" anchor="t" lIns="45720" rIns="45720" tIns="27432" bIns="27432">
+            <a:spAutoFit/>
+          </a:bodyPr>
+          <a:lstStyle/>
+          <a:p>
+            <a:pPr algn="l">
+              <a:spcAft>
+                <a:spcPts val="600"/>
+              </a:spcAft>
+            </a:pPr>
+            <a:r>
+              <a:rPr sz="1600" b="0">
+                <a:solidFill>
+                  <a:srgbClr val="444F5A"/>
+                </a:solidFill>
+                <a:latin typeface="Calibri"/>
+              </a:rPr>
+              <a:t>No clinical validation or testing with real patients</a:t>
+            </a:r>
+          </a:p>
+          <a:p>
+            <a:pPr algn="l">
+              <a:spcAft>
+                <a:spcPts val="600"/>
+              </a:spcAft>
+            </a:pPr>
+            <a:r>
+              <a:rPr sz="1600" b="0">
+                <a:solidFill>
+                  <a:srgbClr val="444F5A"/>
+                </a:solidFill>
+                <a:latin typeface="Calibri"/>
+              </a:rPr>
+              <a:t>No review of the urgent and moderate lists by a doctor or nurse</a:t>
+            </a:r>
+          </a:p>
+          <a:p>
+            <a:pPr algn="l">
+              <a:spcAft>
+                <a:spcPts val="600"/>
+              </a:spcAft>
+            </a:pPr>
+            <a:r>
+              <a:rPr sz="1600" b="0">
+                <a:solidFill>
+                  <a:srgbClr val="444F5A"/>
+                </a:solidFill>
+                <a:latin typeface="Calibri"/>
+              </a:rPr>
+              <a:t>No handling of children, pregnancy or chronic conditions</a:t>
+            </a:r>
+          </a:p>
+          <a:p>
+            <a:pPr algn="l">
+              <a:spcAft>
+                <a:spcPts val="600"/>
+              </a:spcAft>
+            </a:pPr>
+            <a:r>
+              <a:rPr sz="1600" b="0">
+                <a:solidFill>
+                  <a:srgbClr val="444F5A"/>
+                </a:solidFill>
+                <a:latin typeface="Calibri"/>
+              </a:rPr>
+              <a:t>No local-language or pidgin phrasing</a:t>
+            </a:r>
+          </a:p>
+          <a:p>
+            <a:pPr algn="l">
+              <a:spcAft>
+                <a:spcPts val="600"/>
+              </a:spcAft>
+            </a:pPr>
+            <a:r>
+              <a:rPr sz="1600" b="0">
+                <a:solidFill>
+                  <a:srgbClr val="444F5A"/>
+                </a:solidFill>
+                <a:latin typeface="Calibri"/>
+              </a:rPr>
+              <a:t>No real clinic directory</a:t>
+            </a:r>
+          </a:p>
+        </p:txBody>
+      </p:sp>
+    </p:spTree>
+  </p:cSld>
+  <p:clrMapOvr>
+    <a:masterClrMapping/>
+  </p:clrMapOvr>
+</p:sld>
+</file>
+
+<file path=ppt/slides/slide7.xml><?xml version="1.0" encoding="utf-8"?>
+<p:sld xmlns:a="http://schemas.openxmlformats.org/drawingml/2006/main" xmlns:p="http://schemas.openxmlformats.org/presentationml/2006/main" xmlns:r="http://schemas.openxmlformats.org/officeDocument/2006/relationships">
+  <p:cSld>
+    <p:spTree>
+      <p:nvGrpSpPr>
+        <p:cNvPr id="1" name=""/>
+        <p:cNvGrpSpPr/>
+        <p:nvPr/>
+      </p:nvGrpSpPr>
+      <p:grpSpPr/>
+      <p:sp>
+        <p:nvSpPr>
+          <p:cNvPr id="2" name="Rectangle 1"/>
+          <p:cNvSpPr/>
+          <p:nvPr/>
+        </p:nvSpPr>
+        <p:spPr>
+          <a:xfrm>
+            <a:off x="0" y="0"/>
+            <a:ext cx="12191695" cy="1143000"/>
+          </a:xfrm>
+          <a:prstGeom prst="rect">
+            <a:avLst/>
+          </a:prstGeom>
+          <a:solidFill>
+            <a:srgbClr val="0B2A4A"/>
+          </a:solidFill>
+          <a:ln>
+            <a:noFill/>
+          </a:ln>
+          <a:effectLst/>
+        </p:spPr>
+        <p:style>
+          <a:lnRef idx="1">
+            <a:schemeClr val="accent1"/>
+          </a:lnRef>
+          <a:fillRef idx="3">
+            <a:schemeClr val="accent1"/>
+          </a:fillRef>
+          <a:effectRef idx="2">
+            <a:schemeClr val="accent1"/>
+          </a:effectRef>
+          <a:fontRef idx="minor">
+            <a:schemeClr val="lt1"/>
+          </a:fontRef>
+        </p:style>
+        <p:txBody>
+          <a:bodyPr rtlCol="0" anchor="ctr"/>
+          <a:lstStyle/>
+          <a:p>
+            <a:pPr algn="ctr"/>
+          </a:p>
+        </p:txBody>
+      </p:sp>
+      <p:sp>
+        <p:nvSpPr>
+          <p:cNvPr id="3" name="TextBox 2"/>
+          <p:cNvSpPr txBox="1"/>
+          <p:nvPr/>
+        </p:nvSpPr>
+        <p:spPr>
+          <a:xfrm>
+            <a:off x="548640" y="201168"/>
+            <a:ext cx="10241280" cy="731520"/>
+          </a:xfrm>
+          <a:prstGeom prst="rect">
+            <a:avLst/>
+          </a:prstGeom>
+          <a:noFill/>
+        </p:spPr>
+        <p:txBody>
+          <a:bodyPr wrap="square" anchor="ctr" lIns="45720" rIns="45720" tIns="27432" bIns="27432">
+            <a:spAutoFit/>
+          </a:bodyPr>
+          <a:lstStyle/>
+          <a:p>
+            <a:pPr algn="l">
+              <a:spcAft>
+                <a:spcPts val="600"/>
+              </a:spcAft>
+            </a:pPr>
+            <a:r>
+              <a:rPr sz="3200" b="1">
+                <a:solidFill>
+                  <a:srgbClr val="FFFFFF"/>
+                </a:solidFill>
+                <a:latin typeface="Calibri"/>
+              </a:rPr>
+              <a:t>What we are asking of you</a:t>
+            </a:r>
+          </a:p>
+        </p:txBody>
+      </p:sp>
+      <p:sp>
+        <p:nvSpPr>
+          <p:cNvPr id="4" name="TextBox 3"/>
+          <p:cNvSpPr txBox="1"/>
+          <p:nvPr/>
+        </p:nvSpPr>
+        <p:spPr>
+          <a:xfrm>
+            <a:off x="10607040" y="365760"/>
+            <a:ext cx="1280160" cy="457200"/>
+          </a:xfrm>
+          <a:prstGeom prst="rect">
+            <a:avLst/>
+          </a:prstGeom>
+          <a:noFill/>
+        </p:spPr>
+        <p:txBody>
+          <a:bodyPr wrap="square" anchor="t" lIns="45720" rIns="45720" tIns="27432" bIns="27432">
+            <a:spAutoFit/>
+          </a:bodyPr>
+          <a:lstStyle/>
+          <a:p>
+            <a:pPr algn="r">
+              <a:spcAft>
+                <a:spcPts val="600"/>
+              </a:spcAft>
+            </a:pPr>
+            <a:r>
+              <a:rPr sz="1600" b="0">
+                <a:solidFill>
+                  <a:srgbClr val="BFD4E6"/>
+                </a:solidFill>
+                <a:latin typeface="Calibri"/>
+              </a:rPr>
+              <a:t>7 / 7</a:t>
             </a:r>
           </a:p>
         </p:txBody>

</xml_diff>